<commit_message>
Make the variant B watermark smaller and fainter
Centred emblem goes from 5.9" at 89% transparency to 4.5" at 93%, so it
reads as a light ground texture rather than competing with the title.

Co-Authored-By: Claude Opus 5 <noreply@anthropic.com>
Claude-Session: https://claude.ai/code/session_01GZfitk2JEKppZ4fGSDdghv
</commit_message>
<xml_diff>
--- a/docs/2027년_사무직원_채용계획안_B_중앙워터마크.pptx
+++ b/docs/2027년_사무직원_채용계획안_B_중앙워터마크.pptx
@@ -1962,7 +1962,7 @@
         </p:nvPicPr>
         <p:blipFill>
           <a:blip r:embed="rId1">
-            <a:alphaModFix amt="11000"/>
+            <a:alphaModFix amt="7000"/>
           </a:blip>
           <a:stretch>
             <a:fillRect/>
@@ -1970,8 +1970,8 @@
         </p:blipFill>
         <p:spPr>
           <a:xfrm>
-            <a:off x="3383280" y="731520"/>
-            <a:ext cx="5394960" cy="5394960"/>
+            <a:off x="4023360" y="1371600"/>
+            <a:ext cx="4114800" cy="4114800"/>
           </a:xfrm>
           <a:prstGeom prst="rect">
             <a:avLst/>

</xml_diff>